<commit_message>
FileDetails struct now stores the filename
</commit_message>
<xml_diff>
--- a/demo_presentation_1.pptx
+++ b/demo_presentation_1.pptx
@@ -3113,7 +3113,7 @@
           <a:lstStyle/>
           <a:p>
             <a:r>
-              <a:t>Demo Presentation 1 - Slide 1</a:t>
+              <a:t>Demo PPTX 1 - Slide 1</a:t>
             </a:r>
           </a:p>
         </p:txBody>
@@ -3134,19 +3134,80 @@
           <a:lstStyle/>
           <a:p>
             <a:r>
-              <a:t>This is slide 1.</a:t>
-            </a:r>
-          </a:p>
-          <a:p>
-            <a:r>
-              <a:t>Contains sample bullet points and content for parser testing.</a:t>
-            </a:r>
-          </a:p>
-          <a:p>
-            <a:r>
-              <a:t>Presentation #1.</a:t>
-            </a:r>
-          </a:p>
+              <a:t>Sample bullet content for parsing.</a:t>
+            </a:r>
+          </a:p>
+          <a:p>
+            <a:r>
+              <a:t>Sample bullet content for parsing.</a:t>
+            </a:r>
+          </a:p>
+          <a:p>
+            <a:r>
+              <a:t>Sample bullet content for parsing.</a:t>
+            </a:r>
+          </a:p>
+          <a:p>
+            <a:r>
+              <a:t>Sample bullet content for parsing.</a:t>
+            </a:r>
+          </a:p>
+          <a:p>
+            <a:r>
+              <a:t>Sample bullet content for parsing.</a:t>
+            </a:r>
+          </a:p>
+          <a:p>
+            <a:r>
+              <a:t>Sample bullet content for parsing.</a:t>
+            </a:r>
+          </a:p>
+          <a:p>
+            <a:r>
+              <a:t>Sample bullet content for parsing.</a:t>
+            </a:r>
+          </a:p>
+          <a:p>
+            <a:r>
+              <a:t>Sample bullet content for parsing.</a:t>
+            </a:r>
+          </a:p>
+          <a:p>
+            <a:r>
+              <a:t>Sample bullet content for parsing.</a:t>
+            </a:r>
+          </a:p>
+          <a:p>
+            <a:r>
+              <a:t>Sample bullet content for parsing.</a:t>
+            </a:r>
+          </a:p>
+          <a:p>
+            <a:r>
+              <a:t>Sample bullet content for parsing.</a:t>
+            </a:r>
+          </a:p>
+          <a:p>
+            <a:r>
+              <a:t>Sample bullet content for parsing.</a:t>
+            </a:r>
+          </a:p>
+          <a:p>
+            <a:r>
+              <a:t>Sample bullet content for parsing.</a:t>
+            </a:r>
+          </a:p>
+          <a:p>
+            <a:r>
+              <a:t>Sample bullet content for parsing.</a:t>
+            </a:r>
+          </a:p>
+          <a:p>
+            <a:r>
+              <a:t>Sample bullet content for parsing.</a:t>
+            </a:r>
+          </a:p>
+          <a:p/>
         </p:txBody>
       </p:sp>
     </p:spTree>
@@ -3183,7 +3244,7 @@
           <a:lstStyle/>
           <a:p>
             <a:r>
-              <a:t>Demo Presentation 1 - Slide 10</a:t>
+              <a:t>Demo PPTX 1 - Slide 10</a:t>
             </a:r>
           </a:p>
         </p:txBody>
@@ -3204,19 +3265,80 @@
           <a:lstStyle/>
           <a:p>
             <a:r>
-              <a:t>This is slide 10.</a:t>
-            </a:r>
-          </a:p>
-          <a:p>
-            <a:r>
-              <a:t>Contains sample bullet points and content for parser testing.</a:t>
-            </a:r>
-          </a:p>
-          <a:p>
-            <a:r>
-              <a:t>Presentation #1.</a:t>
-            </a:r>
-          </a:p>
+              <a:t>Sample bullet content for parsing.</a:t>
+            </a:r>
+          </a:p>
+          <a:p>
+            <a:r>
+              <a:t>Sample bullet content for parsing.</a:t>
+            </a:r>
+          </a:p>
+          <a:p>
+            <a:r>
+              <a:t>Sample bullet content for parsing.</a:t>
+            </a:r>
+          </a:p>
+          <a:p>
+            <a:r>
+              <a:t>Sample bullet content for parsing.</a:t>
+            </a:r>
+          </a:p>
+          <a:p>
+            <a:r>
+              <a:t>Sample bullet content for parsing.</a:t>
+            </a:r>
+          </a:p>
+          <a:p>
+            <a:r>
+              <a:t>Sample bullet content for parsing.</a:t>
+            </a:r>
+          </a:p>
+          <a:p>
+            <a:r>
+              <a:t>Sample bullet content for parsing.</a:t>
+            </a:r>
+          </a:p>
+          <a:p>
+            <a:r>
+              <a:t>Sample bullet content for parsing.</a:t>
+            </a:r>
+          </a:p>
+          <a:p>
+            <a:r>
+              <a:t>Sample bullet content for parsing.</a:t>
+            </a:r>
+          </a:p>
+          <a:p>
+            <a:r>
+              <a:t>Sample bullet content for parsing.</a:t>
+            </a:r>
+          </a:p>
+          <a:p>
+            <a:r>
+              <a:t>Sample bullet content for parsing.</a:t>
+            </a:r>
+          </a:p>
+          <a:p>
+            <a:r>
+              <a:t>Sample bullet content for parsing.</a:t>
+            </a:r>
+          </a:p>
+          <a:p>
+            <a:r>
+              <a:t>Sample bullet content for parsing.</a:t>
+            </a:r>
+          </a:p>
+          <a:p>
+            <a:r>
+              <a:t>Sample bullet content for parsing.</a:t>
+            </a:r>
+          </a:p>
+          <a:p>
+            <a:r>
+              <a:t>Sample bullet content for parsing.</a:t>
+            </a:r>
+          </a:p>
+          <a:p/>
         </p:txBody>
       </p:sp>
     </p:spTree>
@@ -3253,7 +3375,7 @@
           <a:lstStyle/>
           <a:p>
             <a:r>
-              <a:t>Demo Presentation 1 - Slide 2</a:t>
+              <a:t>Demo PPTX 1 - Slide 2</a:t>
             </a:r>
           </a:p>
         </p:txBody>
@@ -3274,19 +3396,80 @@
           <a:lstStyle/>
           <a:p>
             <a:r>
-              <a:t>This is slide 2.</a:t>
-            </a:r>
-          </a:p>
-          <a:p>
-            <a:r>
-              <a:t>Contains sample bullet points and content for parser testing.</a:t>
-            </a:r>
-          </a:p>
-          <a:p>
-            <a:r>
-              <a:t>Presentation #1.</a:t>
-            </a:r>
-          </a:p>
+              <a:t>Sample bullet content for parsing.</a:t>
+            </a:r>
+          </a:p>
+          <a:p>
+            <a:r>
+              <a:t>Sample bullet content for parsing.</a:t>
+            </a:r>
+          </a:p>
+          <a:p>
+            <a:r>
+              <a:t>Sample bullet content for parsing.</a:t>
+            </a:r>
+          </a:p>
+          <a:p>
+            <a:r>
+              <a:t>Sample bullet content for parsing.</a:t>
+            </a:r>
+          </a:p>
+          <a:p>
+            <a:r>
+              <a:t>Sample bullet content for parsing.</a:t>
+            </a:r>
+          </a:p>
+          <a:p>
+            <a:r>
+              <a:t>Sample bullet content for parsing.</a:t>
+            </a:r>
+          </a:p>
+          <a:p>
+            <a:r>
+              <a:t>Sample bullet content for parsing.</a:t>
+            </a:r>
+          </a:p>
+          <a:p>
+            <a:r>
+              <a:t>Sample bullet content for parsing.</a:t>
+            </a:r>
+          </a:p>
+          <a:p>
+            <a:r>
+              <a:t>Sample bullet content for parsing.</a:t>
+            </a:r>
+          </a:p>
+          <a:p>
+            <a:r>
+              <a:t>Sample bullet content for parsing.</a:t>
+            </a:r>
+          </a:p>
+          <a:p>
+            <a:r>
+              <a:t>Sample bullet content for parsing.</a:t>
+            </a:r>
+          </a:p>
+          <a:p>
+            <a:r>
+              <a:t>Sample bullet content for parsing.</a:t>
+            </a:r>
+          </a:p>
+          <a:p>
+            <a:r>
+              <a:t>Sample bullet content for parsing.</a:t>
+            </a:r>
+          </a:p>
+          <a:p>
+            <a:r>
+              <a:t>Sample bullet content for parsing.</a:t>
+            </a:r>
+          </a:p>
+          <a:p>
+            <a:r>
+              <a:t>Sample bullet content for parsing.</a:t>
+            </a:r>
+          </a:p>
+          <a:p/>
         </p:txBody>
       </p:sp>
     </p:spTree>
@@ -3323,7 +3506,7 @@
           <a:lstStyle/>
           <a:p>
             <a:r>
-              <a:t>Demo Presentation 1 - Slide 3</a:t>
+              <a:t>Demo PPTX 1 - Slide 3</a:t>
             </a:r>
           </a:p>
         </p:txBody>
@@ -3344,19 +3527,80 @@
           <a:lstStyle/>
           <a:p>
             <a:r>
-              <a:t>This is slide 3.</a:t>
-            </a:r>
-          </a:p>
-          <a:p>
-            <a:r>
-              <a:t>Contains sample bullet points and content for parser testing.</a:t>
-            </a:r>
-          </a:p>
-          <a:p>
-            <a:r>
-              <a:t>Presentation #1.</a:t>
-            </a:r>
-          </a:p>
+              <a:t>Sample bullet content for parsing.</a:t>
+            </a:r>
+          </a:p>
+          <a:p>
+            <a:r>
+              <a:t>Sample bullet content for parsing.</a:t>
+            </a:r>
+          </a:p>
+          <a:p>
+            <a:r>
+              <a:t>Sample bullet content for parsing.</a:t>
+            </a:r>
+          </a:p>
+          <a:p>
+            <a:r>
+              <a:t>Sample bullet content for parsing.</a:t>
+            </a:r>
+          </a:p>
+          <a:p>
+            <a:r>
+              <a:t>Sample bullet content for parsing.</a:t>
+            </a:r>
+          </a:p>
+          <a:p>
+            <a:r>
+              <a:t>Sample bullet content for parsing.</a:t>
+            </a:r>
+          </a:p>
+          <a:p>
+            <a:r>
+              <a:t>Sample bullet content for parsing.</a:t>
+            </a:r>
+          </a:p>
+          <a:p>
+            <a:r>
+              <a:t>Sample bullet content for parsing.</a:t>
+            </a:r>
+          </a:p>
+          <a:p>
+            <a:r>
+              <a:t>Sample bullet content for parsing.</a:t>
+            </a:r>
+          </a:p>
+          <a:p>
+            <a:r>
+              <a:t>Sample bullet content for parsing.</a:t>
+            </a:r>
+          </a:p>
+          <a:p>
+            <a:r>
+              <a:t>Sample bullet content for parsing.</a:t>
+            </a:r>
+          </a:p>
+          <a:p>
+            <a:r>
+              <a:t>Sample bullet content for parsing.</a:t>
+            </a:r>
+          </a:p>
+          <a:p>
+            <a:r>
+              <a:t>Sample bullet content for parsing.</a:t>
+            </a:r>
+          </a:p>
+          <a:p>
+            <a:r>
+              <a:t>Sample bullet content for parsing.</a:t>
+            </a:r>
+          </a:p>
+          <a:p>
+            <a:r>
+              <a:t>Sample bullet content for parsing.</a:t>
+            </a:r>
+          </a:p>
+          <a:p/>
         </p:txBody>
       </p:sp>
     </p:spTree>
@@ -3393,7 +3637,7 @@
           <a:lstStyle/>
           <a:p>
             <a:r>
-              <a:t>Demo Presentation 1 - Slide 4</a:t>
+              <a:t>Demo PPTX 1 - Slide 4</a:t>
             </a:r>
           </a:p>
         </p:txBody>
@@ -3414,19 +3658,80 @@
           <a:lstStyle/>
           <a:p>
             <a:r>
-              <a:t>This is slide 4.</a:t>
-            </a:r>
-          </a:p>
-          <a:p>
-            <a:r>
-              <a:t>Contains sample bullet points and content for parser testing.</a:t>
-            </a:r>
-          </a:p>
-          <a:p>
-            <a:r>
-              <a:t>Presentation #1.</a:t>
-            </a:r>
-          </a:p>
+              <a:t>Sample bullet content for parsing.</a:t>
+            </a:r>
+          </a:p>
+          <a:p>
+            <a:r>
+              <a:t>Sample bullet content for parsing.</a:t>
+            </a:r>
+          </a:p>
+          <a:p>
+            <a:r>
+              <a:t>Sample bullet content for parsing.</a:t>
+            </a:r>
+          </a:p>
+          <a:p>
+            <a:r>
+              <a:t>Sample bullet content for parsing.</a:t>
+            </a:r>
+          </a:p>
+          <a:p>
+            <a:r>
+              <a:t>Sample bullet content for parsing.</a:t>
+            </a:r>
+          </a:p>
+          <a:p>
+            <a:r>
+              <a:t>Sample bullet content for parsing.</a:t>
+            </a:r>
+          </a:p>
+          <a:p>
+            <a:r>
+              <a:t>Sample bullet content for parsing.</a:t>
+            </a:r>
+          </a:p>
+          <a:p>
+            <a:r>
+              <a:t>Sample bullet content for parsing.</a:t>
+            </a:r>
+          </a:p>
+          <a:p>
+            <a:r>
+              <a:t>Sample bullet content for parsing.</a:t>
+            </a:r>
+          </a:p>
+          <a:p>
+            <a:r>
+              <a:t>Sample bullet content for parsing.</a:t>
+            </a:r>
+          </a:p>
+          <a:p>
+            <a:r>
+              <a:t>Sample bullet content for parsing.</a:t>
+            </a:r>
+          </a:p>
+          <a:p>
+            <a:r>
+              <a:t>Sample bullet content for parsing.</a:t>
+            </a:r>
+          </a:p>
+          <a:p>
+            <a:r>
+              <a:t>Sample bullet content for parsing.</a:t>
+            </a:r>
+          </a:p>
+          <a:p>
+            <a:r>
+              <a:t>Sample bullet content for parsing.</a:t>
+            </a:r>
+          </a:p>
+          <a:p>
+            <a:r>
+              <a:t>Sample bullet content for parsing.</a:t>
+            </a:r>
+          </a:p>
+          <a:p/>
         </p:txBody>
       </p:sp>
     </p:spTree>
@@ -3463,7 +3768,7 @@
           <a:lstStyle/>
           <a:p>
             <a:r>
-              <a:t>Demo Presentation 1 - Slide 5</a:t>
+              <a:t>Demo PPTX 1 - Slide 5</a:t>
             </a:r>
           </a:p>
         </p:txBody>
@@ -3484,19 +3789,80 @@
           <a:lstStyle/>
           <a:p>
             <a:r>
-              <a:t>This is slide 5.</a:t>
-            </a:r>
-          </a:p>
-          <a:p>
-            <a:r>
-              <a:t>Contains sample bullet points and content for parser testing.</a:t>
-            </a:r>
-          </a:p>
-          <a:p>
-            <a:r>
-              <a:t>Presentation #1.</a:t>
-            </a:r>
-          </a:p>
+              <a:t>Sample bullet content for parsing.</a:t>
+            </a:r>
+          </a:p>
+          <a:p>
+            <a:r>
+              <a:t>Sample bullet content for parsing.</a:t>
+            </a:r>
+          </a:p>
+          <a:p>
+            <a:r>
+              <a:t>Sample bullet content for parsing.</a:t>
+            </a:r>
+          </a:p>
+          <a:p>
+            <a:r>
+              <a:t>Sample bullet content for parsing.</a:t>
+            </a:r>
+          </a:p>
+          <a:p>
+            <a:r>
+              <a:t>Sample bullet content for parsing.</a:t>
+            </a:r>
+          </a:p>
+          <a:p>
+            <a:r>
+              <a:t>Sample bullet content for parsing.</a:t>
+            </a:r>
+          </a:p>
+          <a:p>
+            <a:r>
+              <a:t>Sample bullet content for parsing.</a:t>
+            </a:r>
+          </a:p>
+          <a:p>
+            <a:r>
+              <a:t>Sample bullet content for parsing.</a:t>
+            </a:r>
+          </a:p>
+          <a:p>
+            <a:r>
+              <a:t>Sample bullet content for parsing.</a:t>
+            </a:r>
+          </a:p>
+          <a:p>
+            <a:r>
+              <a:t>Sample bullet content for parsing.</a:t>
+            </a:r>
+          </a:p>
+          <a:p>
+            <a:r>
+              <a:t>Sample bullet content for parsing.</a:t>
+            </a:r>
+          </a:p>
+          <a:p>
+            <a:r>
+              <a:t>Sample bullet content for parsing.</a:t>
+            </a:r>
+          </a:p>
+          <a:p>
+            <a:r>
+              <a:t>Sample bullet content for parsing.</a:t>
+            </a:r>
+          </a:p>
+          <a:p>
+            <a:r>
+              <a:t>Sample bullet content for parsing.</a:t>
+            </a:r>
+          </a:p>
+          <a:p>
+            <a:r>
+              <a:t>Sample bullet content for parsing.</a:t>
+            </a:r>
+          </a:p>
+          <a:p/>
         </p:txBody>
       </p:sp>
     </p:spTree>
@@ -3533,7 +3899,7 @@
           <a:lstStyle/>
           <a:p>
             <a:r>
-              <a:t>Demo Presentation 1 - Slide 6</a:t>
+              <a:t>Demo PPTX 1 - Slide 6</a:t>
             </a:r>
           </a:p>
         </p:txBody>
@@ -3554,19 +3920,80 @@
           <a:lstStyle/>
           <a:p>
             <a:r>
-              <a:t>This is slide 6.</a:t>
-            </a:r>
-          </a:p>
-          <a:p>
-            <a:r>
-              <a:t>Contains sample bullet points and content for parser testing.</a:t>
-            </a:r>
-          </a:p>
-          <a:p>
-            <a:r>
-              <a:t>Presentation #1.</a:t>
-            </a:r>
-          </a:p>
+              <a:t>Sample bullet content for parsing.</a:t>
+            </a:r>
+          </a:p>
+          <a:p>
+            <a:r>
+              <a:t>Sample bullet content for parsing.</a:t>
+            </a:r>
+          </a:p>
+          <a:p>
+            <a:r>
+              <a:t>Sample bullet content for parsing.</a:t>
+            </a:r>
+          </a:p>
+          <a:p>
+            <a:r>
+              <a:t>Sample bullet content for parsing.</a:t>
+            </a:r>
+          </a:p>
+          <a:p>
+            <a:r>
+              <a:t>Sample bullet content for parsing.</a:t>
+            </a:r>
+          </a:p>
+          <a:p>
+            <a:r>
+              <a:t>Sample bullet content for parsing.</a:t>
+            </a:r>
+          </a:p>
+          <a:p>
+            <a:r>
+              <a:t>Sample bullet content for parsing.</a:t>
+            </a:r>
+          </a:p>
+          <a:p>
+            <a:r>
+              <a:t>Sample bullet content for parsing.</a:t>
+            </a:r>
+          </a:p>
+          <a:p>
+            <a:r>
+              <a:t>Sample bullet content for parsing.</a:t>
+            </a:r>
+          </a:p>
+          <a:p>
+            <a:r>
+              <a:t>Sample bullet content for parsing.</a:t>
+            </a:r>
+          </a:p>
+          <a:p>
+            <a:r>
+              <a:t>Sample bullet content for parsing.</a:t>
+            </a:r>
+          </a:p>
+          <a:p>
+            <a:r>
+              <a:t>Sample bullet content for parsing.</a:t>
+            </a:r>
+          </a:p>
+          <a:p>
+            <a:r>
+              <a:t>Sample bullet content for parsing.</a:t>
+            </a:r>
+          </a:p>
+          <a:p>
+            <a:r>
+              <a:t>Sample bullet content for parsing.</a:t>
+            </a:r>
+          </a:p>
+          <a:p>
+            <a:r>
+              <a:t>Sample bullet content for parsing.</a:t>
+            </a:r>
+          </a:p>
+          <a:p/>
         </p:txBody>
       </p:sp>
     </p:spTree>
@@ -3603,7 +4030,7 @@
           <a:lstStyle/>
           <a:p>
             <a:r>
-              <a:t>Demo Presentation 1 - Slide 7</a:t>
+              <a:t>Demo PPTX 1 - Slide 7</a:t>
             </a:r>
           </a:p>
         </p:txBody>
@@ -3624,19 +4051,80 @@
           <a:lstStyle/>
           <a:p>
             <a:r>
-              <a:t>This is slide 7.</a:t>
-            </a:r>
-          </a:p>
-          <a:p>
-            <a:r>
-              <a:t>Contains sample bullet points and content for parser testing.</a:t>
-            </a:r>
-          </a:p>
-          <a:p>
-            <a:r>
-              <a:t>Presentation #1.</a:t>
-            </a:r>
-          </a:p>
+              <a:t>Sample bullet content for parsing.</a:t>
+            </a:r>
+          </a:p>
+          <a:p>
+            <a:r>
+              <a:t>Sample bullet content for parsing.</a:t>
+            </a:r>
+          </a:p>
+          <a:p>
+            <a:r>
+              <a:t>Sample bullet content for parsing.</a:t>
+            </a:r>
+          </a:p>
+          <a:p>
+            <a:r>
+              <a:t>Sample bullet content for parsing.</a:t>
+            </a:r>
+          </a:p>
+          <a:p>
+            <a:r>
+              <a:t>Sample bullet content for parsing.</a:t>
+            </a:r>
+          </a:p>
+          <a:p>
+            <a:r>
+              <a:t>Sample bullet content for parsing.</a:t>
+            </a:r>
+          </a:p>
+          <a:p>
+            <a:r>
+              <a:t>Sample bullet content for parsing.</a:t>
+            </a:r>
+          </a:p>
+          <a:p>
+            <a:r>
+              <a:t>Sample bullet content for parsing.</a:t>
+            </a:r>
+          </a:p>
+          <a:p>
+            <a:r>
+              <a:t>Sample bullet content for parsing.</a:t>
+            </a:r>
+          </a:p>
+          <a:p>
+            <a:r>
+              <a:t>Sample bullet content for parsing.</a:t>
+            </a:r>
+          </a:p>
+          <a:p>
+            <a:r>
+              <a:t>Sample bullet content for parsing.</a:t>
+            </a:r>
+          </a:p>
+          <a:p>
+            <a:r>
+              <a:t>Sample bullet content for parsing.</a:t>
+            </a:r>
+          </a:p>
+          <a:p>
+            <a:r>
+              <a:t>Sample bullet content for parsing.</a:t>
+            </a:r>
+          </a:p>
+          <a:p>
+            <a:r>
+              <a:t>Sample bullet content for parsing.</a:t>
+            </a:r>
+          </a:p>
+          <a:p>
+            <a:r>
+              <a:t>Sample bullet content for parsing.</a:t>
+            </a:r>
+          </a:p>
+          <a:p/>
         </p:txBody>
       </p:sp>
     </p:spTree>
@@ -3673,7 +4161,7 @@
           <a:lstStyle/>
           <a:p>
             <a:r>
-              <a:t>Demo Presentation 1 - Slide 8</a:t>
+              <a:t>Demo PPTX 1 - Slide 8</a:t>
             </a:r>
           </a:p>
         </p:txBody>
@@ -3694,19 +4182,80 @@
           <a:lstStyle/>
           <a:p>
             <a:r>
-              <a:t>This is slide 8.</a:t>
-            </a:r>
-          </a:p>
-          <a:p>
-            <a:r>
-              <a:t>Contains sample bullet points and content for parser testing.</a:t>
-            </a:r>
-          </a:p>
-          <a:p>
-            <a:r>
-              <a:t>Presentation #1.</a:t>
-            </a:r>
-          </a:p>
+              <a:t>Sample bullet content for parsing.</a:t>
+            </a:r>
+          </a:p>
+          <a:p>
+            <a:r>
+              <a:t>Sample bullet content for parsing.</a:t>
+            </a:r>
+          </a:p>
+          <a:p>
+            <a:r>
+              <a:t>Sample bullet content for parsing.</a:t>
+            </a:r>
+          </a:p>
+          <a:p>
+            <a:r>
+              <a:t>Sample bullet content for parsing.</a:t>
+            </a:r>
+          </a:p>
+          <a:p>
+            <a:r>
+              <a:t>Sample bullet content for parsing.</a:t>
+            </a:r>
+          </a:p>
+          <a:p>
+            <a:r>
+              <a:t>Sample bullet content for parsing.</a:t>
+            </a:r>
+          </a:p>
+          <a:p>
+            <a:r>
+              <a:t>Sample bullet content for parsing.</a:t>
+            </a:r>
+          </a:p>
+          <a:p>
+            <a:r>
+              <a:t>Sample bullet content for parsing.</a:t>
+            </a:r>
+          </a:p>
+          <a:p>
+            <a:r>
+              <a:t>Sample bullet content for parsing.</a:t>
+            </a:r>
+          </a:p>
+          <a:p>
+            <a:r>
+              <a:t>Sample bullet content for parsing.</a:t>
+            </a:r>
+          </a:p>
+          <a:p>
+            <a:r>
+              <a:t>Sample bullet content for parsing.</a:t>
+            </a:r>
+          </a:p>
+          <a:p>
+            <a:r>
+              <a:t>Sample bullet content for parsing.</a:t>
+            </a:r>
+          </a:p>
+          <a:p>
+            <a:r>
+              <a:t>Sample bullet content for parsing.</a:t>
+            </a:r>
+          </a:p>
+          <a:p>
+            <a:r>
+              <a:t>Sample bullet content for parsing.</a:t>
+            </a:r>
+          </a:p>
+          <a:p>
+            <a:r>
+              <a:t>Sample bullet content for parsing.</a:t>
+            </a:r>
+          </a:p>
+          <a:p/>
         </p:txBody>
       </p:sp>
     </p:spTree>
@@ -3743,7 +4292,7 @@
           <a:lstStyle/>
           <a:p>
             <a:r>
-              <a:t>Demo Presentation 1 - Slide 9</a:t>
+              <a:t>Demo PPTX 1 - Slide 9</a:t>
             </a:r>
           </a:p>
         </p:txBody>
@@ -3764,19 +4313,80 @@
           <a:lstStyle/>
           <a:p>
             <a:r>
-              <a:t>This is slide 9.</a:t>
-            </a:r>
-          </a:p>
-          <a:p>
-            <a:r>
-              <a:t>Contains sample bullet points and content for parser testing.</a:t>
-            </a:r>
-          </a:p>
-          <a:p>
-            <a:r>
-              <a:t>Presentation #1.</a:t>
-            </a:r>
-          </a:p>
+              <a:t>Sample bullet content for parsing.</a:t>
+            </a:r>
+          </a:p>
+          <a:p>
+            <a:r>
+              <a:t>Sample bullet content for parsing.</a:t>
+            </a:r>
+          </a:p>
+          <a:p>
+            <a:r>
+              <a:t>Sample bullet content for parsing.</a:t>
+            </a:r>
+          </a:p>
+          <a:p>
+            <a:r>
+              <a:t>Sample bullet content for parsing.</a:t>
+            </a:r>
+          </a:p>
+          <a:p>
+            <a:r>
+              <a:t>Sample bullet content for parsing.</a:t>
+            </a:r>
+          </a:p>
+          <a:p>
+            <a:r>
+              <a:t>Sample bullet content for parsing.</a:t>
+            </a:r>
+          </a:p>
+          <a:p>
+            <a:r>
+              <a:t>Sample bullet content for parsing.</a:t>
+            </a:r>
+          </a:p>
+          <a:p>
+            <a:r>
+              <a:t>Sample bullet content for parsing.</a:t>
+            </a:r>
+          </a:p>
+          <a:p>
+            <a:r>
+              <a:t>Sample bullet content for parsing.</a:t>
+            </a:r>
+          </a:p>
+          <a:p>
+            <a:r>
+              <a:t>Sample bullet content for parsing.</a:t>
+            </a:r>
+          </a:p>
+          <a:p>
+            <a:r>
+              <a:t>Sample bullet content for parsing.</a:t>
+            </a:r>
+          </a:p>
+          <a:p>
+            <a:r>
+              <a:t>Sample bullet content for parsing.</a:t>
+            </a:r>
+          </a:p>
+          <a:p>
+            <a:r>
+              <a:t>Sample bullet content for parsing.</a:t>
+            </a:r>
+          </a:p>
+          <a:p>
+            <a:r>
+              <a:t>Sample bullet content for parsing.</a:t>
+            </a:r>
+          </a:p>
+          <a:p>
+            <a:r>
+              <a:t>Sample bullet content for parsing.</a:t>
+            </a:r>
+          </a:p>
+          <a:p/>
         </p:txBody>
       </p:sp>
     </p:spTree>

</xml_diff>